<commit_message>
Add held-out budget evaluation, reliability analysis, and progress report 5
</commit_message>
<xml_diff>
--- a/docs/presentations/CIS631_Project_Progress_Report.pptx
+++ b/docs/presentations/CIS631_Project_Progress_Report.pptx
@@ -116,6 +116,14 @@
       </a:defRPr>
     </a:lvl9pPr>
   </p:defaultTextStyle>
+  <p:extLst>
+    <p:ext uri="{EFAFB233-063F-42B5-8137-9DF3F51BA10A}">
+      <p15:sldGuideLst xmlns:p15="http://schemas.microsoft.com/office/powerpoint/2012/main"/>
+    </p:ext>
+    <p:ext uri="{2D200454-40CA-4A62-9FC3-DE9A4176ACB9}">
+      <p15:notesGuideLst xmlns:p15="http://schemas.microsoft.com/office/powerpoint/2012/main"/>
+    </p:ext>
+  </p:extLst>
 </p:presentation>
 </file>
 
@@ -2349,7 +2357,7 @@
 </file>
 
 <file path=ppt/diagrams/colors2.xml><?xml version="1.0" encoding="utf-8"?>
-<dgm:colorsDef xmlns:dgm="http://schemas.openxmlformats.org/drawingml/2006/diagram" xmlns:a="http://schemas.openxmlformats.org/drawingml/2006/main" uniqueId="urn:microsoft.com/office/officeart/2005/8/colors/colorful4">
+<dgm:colorsDef xmlns:dgm="http://schemas.openxmlformats.org/drawingml/2006/diagram" xmlns:a="http://schemas.openxmlformats.org/drawingml/2006/main" uniqueId="urn:microsoft.com/office/officeart/2005/8/colors/colorful4#1">
   <dgm:title val=""/>
   <dgm:desc val=""/>
   <dgm:catLst>
@@ -3986,7 +3994,7 @@
 </file>
 
 <file path=ppt/diagrams/colors4.xml><?xml version="1.0" encoding="utf-8"?>
-<dgm:colorsDef xmlns:dgm="http://schemas.openxmlformats.org/drawingml/2006/diagram" xmlns:a="http://schemas.openxmlformats.org/drawingml/2006/main" uniqueId="urn:microsoft.com/office/officeart/2005/8/colors/colorful4">
+<dgm:colorsDef xmlns:dgm="http://schemas.openxmlformats.org/drawingml/2006/diagram" xmlns:a="http://schemas.openxmlformats.org/drawingml/2006/main" uniqueId="urn:microsoft.com/office/officeart/2005/8/colors/colorful4#2">
   <dgm:title val=""/>
   <dgm:desc val=""/>
   <dgm:catLst>
@@ -5150,7 +5158,7 @@
 <dgm:dataModel xmlns:dgm="http://schemas.openxmlformats.org/drawingml/2006/diagram" xmlns:a="http://schemas.openxmlformats.org/drawingml/2006/main">
   <dgm:ptLst>
     <dgm:pt modelId="{DE9FCB8C-3B64-4C70-AA13-4A877C64E817}" type="doc">
-      <dgm:prSet loTypeId="urn:microsoft.com/office/officeart/2005/8/layout/list1" loCatId="list" qsTypeId="urn:microsoft.com/office/officeart/2005/8/quickstyle/simple1#6" qsCatId="simple" csTypeId="urn:microsoft.com/office/officeart/2005/8/colors/colorful4" csCatId="colorful" phldr="1"/>
+      <dgm:prSet loTypeId="urn:microsoft.com/office/officeart/2005/8/layout/list1" loCatId="list" qsTypeId="urn:microsoft.com/office/officeart/2005/8/quickstyle/simple1#6" qsCatId="simple" csTypeId="urn:microsoft.com/office/officeart/2005/8/colors/colorful4#1" csCatId="colorful" phldr="1"/>
       <dgm:spPr/>
       <dgm:t>
         <a:bodyPr/>
@@ -5740,10 +5748,10 @@
     <dgm:cxn modelId="{1ED65F3E-9915-4FFF-B5DB-9A87A56CBCFF}" type="presOf" srcId="{8E70BE4C-B9FD-49D1-B8A9-9D6E54A7ADF7}" destId="{425AA531-F6E5-43D0-BD13-335974E7B313}" srcOrd="0" destOrd="0" presId="urn:microsoft.com/office/officeart/2005/8/layout/list1"/>
     <dgm:cxn modelId="{61282D42-BFE6-47C6-907B-D99AB0AC81A1}" type="presOf" srcId="{B8A70D72-2D7F-4757-9381-56C26982318D}" destId="{147102D4-8064-4749-998C-BAEAB9E8E953}" srcOrd="0" destOrd="0" presId="urn:microsoft.com/office/officeart/2005/8/layout/list1"/>
     <dgm:cxn modelId="{41D39842-D9CF-4BA0-B666-D1FA94EA7B49}" type="presOf" srcId="{2F2CEC69-05C9-4E48-A0BD-2133202F9F9E}" destId="{D5D82F6A-ABE5-47CA-BF00-84D991A92AB8}" srcOrd="0" destOrd="0" presId="urn:microsoft.com/office/officeart/2005/8/layout/list1"/>
+    <dgm:cxn modelId="{2F7AF248-9358-4ACA-9F81-F4ED068AF295}" srcId="{DE9FCB8C-3B64-4C70-AA13-4A877C64E817}" destId="{8E70BE4C-B9FD-49D1-B8A9-9D6E54A7ADF7}" srcOrd="3" destOrd="0" parTransId="{63EE9566-E401-485F-B914-F9BCA99BDE23}" sibTransId="{4145D411-893F-4DBD-A18F-8531DB3D20A9}"/>
+    <dgm:cxn modelId="{0884D151-3B97-443E-8D41-2408B5AACE48}" type="presOf" srcId="{B1D35F65-36FB-4D1A-BA81-0C017BE83326}" destId="{379CCEAD-094D-497B-A3AD-5D5A96D2A283}" srcOrd="0" destOrd="0" presId="urn:microsoft.com/office/officeart/2005/8/layout/list1"/>
     <dgm:cxn modelId="{06F09F63-9944-4CCB-AD2C-3CFB93027BCD}" srcId="{2F2CEC69-05C9-4E48-A0BD-2133202F9F9E}" destId="{BDF4061A-2454-47F8-A1C5-B62B74BA7A4E}" srcOrd="0" destOrd="0" parTransId="{97D940DE-65C1-42B1-932F-F002BE1E95AD}" sibTransId="{43A3D5E4-00E7-4D29-ACCE-3E24C90EF562}"/>
-    <dgm:cxn modelId="{2F7AF248-9358-4ACA-9F81-F4ED068AF295}" srcId="{DE9FCB8C-3B64-4C70-AA13-4A877C64E817}" destId="{8E70BE4C-B9FD-49D1-B8A9-9D6E54A7ADF7}" srcOrd="3" destOrd="0" parTransId="{63EE9566-E401-485F-B914-F9BCA99BDE23}" sibTransId="{4145D411-893F-4DBD-A18F-8531DB3D20A9}"/>
     <dgm:cxn modelId="{F641336B-ABF0-4BD3-9A41-684E4CA7A7AE}" type="presOf" srcId="{C34F98C0-CA1E-409C-9E86-8257325F843E}" destId="{8AAA8F92-9152-4C18-BF3F-63AA299D7DE1}" srcOrd="1" destOrd="0" presId="urn:microsoft.com/office/officeart/2005/8/layout/list1"/>
-    <dgm:cxn modelId="{0884D151-3B97-443E-8D41-2408B5AACE48}" type="presOf" srcId="{B1D35F65-36FB-4D1A-BA81-0C017BE83326}" destId="{379CCEAD-094D-497B-A3AD-5D5A96D2A283}" srcOrd="0" destOrd="0" presId="urn:microsoft.com/office/officeart/2005/8/layout/list1"/>
     <dgm:cxn modelId="{A193B97B-64D8-4665-9CB9-93E7562CD70E}" type="presOf" srcId="{8E70BE4C-B9FD-49D1-B8A9-9D6E54A7ADF7}" destId="{145DD6A6-AE81-4536-B4E1-39333503775B}" srcOrd="1" destOrd="0" presId="urn:microsoft.com/office/officeart/2005/8/layout/list1"/>
     <dgm:cxn modelId="{14527F7D-C62E-46CE-A5D2-07547F8ECFFE}" type="presOf" srcId="{BDF4061A-2454-47F8-A1C5-B62B74BA7A4E}" destId="{2A180937-4FE6-4819-9661-EFE0CC42F764}" srcOrd="0" destOrd="0" presId="urn:microsoft.com/office/officeart/2005/8/layout/list1"/>
     <dgm:cxn modelId="{BD134591-2FD7-41EB-97FF-C58F92820A88}" srcId="{8E70BE4C-B9FD-49D1-B8A9-9D6E54A7ADF7}" destId="{B1D35F65-36FB-4D1A-BA81-0C017BE83326}" srcOrd="0" destOrd="0" parTransId="{387B75CB-827F-4589-8CB9-A711E83E0EAA}" sibTransId="{C287F2D2-8C55-4C86-A415-9EB18949967E}"/>
@@ -6224,8 +6232,8 @@
   <dgm:cxnLst>
     <dgm:cxn modelId="{5CC2102B-5E0D-43D3-A086-D17508E67836}" type="presOf" srcId="{95EE5851-8584-4532-9D5C-3D82E9F21BC8}" destId="{3B05DB90-5AB6-4FE6-97D9-3CB3F97825C3}" srcOrd="0" destOrd="0" presId="urn:microsoft.com/office/officeart/2018/2/layout/IconVerticalSolidList"/>
     <dgm:cxn modelId="{AD423B3E-5585-4158-ADD5-6C2ABC83C7CC}" srcId="{95EE5851-8584-4532-9D5C-3D82E9F21BC8}" destId="{A1DF0C62-F4AD-4443-969D-3248E3358AAC}" srcOrd="0" destOrd="0" parTransId="{AA9710B0-539A-4255-83B3-5DE7F1001415}" sibTransId="{D27A84E3-F7BB-4D7C-945D-C8936E9E83AE}"/>
+    <dgm:cxn modelId="{739BCE4E-EBE4-4A6F-914D-D26CFA771677}" srcId="{95EE5851-8584-4532-9D5C-3D82E9F21BC8}" destId="{1A39F299-0EDC-459F-8E7E-033C65BCF9D3}" srcOrd="3" destOrd="0" parTransId="{EEC0CC40-7D15-4A6D-8656-4EB32AAC3383}" sibTransId="{A05BFBE9-8A31-49F4-B97A-16C505714A92}"/>
     <dgm:cxn modelId="{3D3C376D-F4C6-40D4-B881-49078D45BB1B}" type="presOf" srcId="{A1DF0C62-F4AD-4443-969D-3248E3358AAC}" destId="{021B03EF-5AFE-4304-A754-E623CC442F7B}" srcOrd="0" destOrd="0" presId="urn:microsoft.com/office/officeart/2018/2/layout/IconVerticalSolidList"/>
-    <dgm:cxn modelId="{739BCE4E-EBE4-4A6F-914D-D26CFA771677}" srcId="{95EE5851-8584-4532-9D5C-3D82E9F21BC8}" destId="{1A39F299-0EDC-459F-8E7E-033C65BCF9D3}" srcOrd="3" destOrd="0" parTransId="{EEC0CC40-7D15-4A6D-8656-4EB32AAC3383}" sibTransId="{A05BFBE9-8A31-49F4-B97A-16C505714A92}"/>
     <dgm:cxn modelId="{D285BD75-5980-43A9-9871-3AFCAF42AF87}" srcId="{95EE5851-8584-4532-9D5C-3D82E9F21BC8}" destId="{C84DD9B4-1524-47EF-9845-FD561CDE6069}" srcOrd="2" destOrd="0" parTransId="{181C39D4-0A9A-4B24-856F-1DFC1490A7AF}" sibTransId="{98B57394-D4E2-499C-9628-EDEFB6BA3F34}"/>
     <dgm:cxn modelId="{82FCDE99-51A0-475F-B3D3-DA0AFD5A8696}" srcId="{95EE5851-8584-4532-9D5C-3D82E9F21BC8}" destId="{6CCF05F2-0306-42C8-976F-5E4B0FE19F96}" srcOrd="1" destOrd="0" parTransId="{C006A59E-91FB-4516-ABD7-69266B5005D4}" sibTransId="{BCDB7AA0-A828-4B9A-8BF7-028FA207BF7D}"/>
     <dgm:cxn modelId="{9F13009B-22C6-4D0E-A155-556E128EBF21}" type="presOf" srcId="{6CCF05F2-0306-42C8-976F-5E4B0FE19F96}" destId="{75CDF874-7B1A-4A7E-9E80-D74C0FAFAC26}" srcOrd="0" destOrd="0" presId="urn:microsoft.com/office/officeart/2018/2/layout/IconVerticalSolidList"/>
@@ -6269,7 +6277,7 @@
 <dgm:dataModel xmlns:dgm="http://schemas.openxmlformats.org/drawingml/2006/diagram" xmlns:a="http://schemas.openxmlformats.org/drawingml/2006/main">
   <dgm:ptLst>
     <dgm:pt modelId="{DE9FCB8C-3B64-4C70-AA13-4A877C64E817}" type="doc">
-      <dgm:prSet loTypeId="urn:microsoft.com/office/officeart/2005/8/layout/list1" loCatId="list" qsTypeId="urn:microsoft.com/office/officeart/2005/8/quickstyle/simple1#6" qsCatId="simple" csTypeId="urn:microsoft.com/office/officeart/2005/8/colors/colorful4" csCatId="colorful" phldr="1"/>
+      <dgm:prSet loTypeId="urn:microsoft.com/office/officeart/2005/8/layout/list1" loCatId="list" qsTypeId="urn:microsoft.com/office/officeart/2005/8/quickstyle/simple1#6" qsCatId="simple" csTypeId="urn:microsoft.com/office/officeart/2005/8/colors/colorful4#2" csCatId="colorful" phldr="1"/>
       <dgm:spPr/>
       <dgm:t>
         <a:bodyPr/>
@@ -6749,9 +6757,9 @@
     <dgm:cxn modelId="{1ED65F3E-9915-4FFF-B5DB-9A87A56CBCFF}" type="presOf" srcId="{8E70BE4C-B9FD-49D1-B8A9-9D6E54A7ADF7}" destId="{425AA531-F6E5-43D0-BD13-335974E7B313}" srcOrd="0" destOrd="0" presId="urn:microsoft.com/office/officeart/2005/8/layout/list1"/>
     <dgm:cxn modelId="{61282D42-BFE6-47C6-907B-D99AB0AC81A1}" type="presOf" srcId="{B8A70D72-2D7F-4757-9381-56C26982318D}" destId="{147102D4-8064-4749-998C-BAEAB9E8E953}" srcOrd="0" destOrd="0" presId="urn:microsoft.com/office/officeart/2005/8/layout/list1"/>
     <dgm:cxn modelId="{41D39842-D9CF-4BA0-B666-D1FA94EA7B49}" type="presOf" srcId="{2F2CEC69-05C9-4E48-A0BD-2133202F9F9E}" destId="{D5D82F6A-ABE5-47CA-BF00-84D991A92AB8}" srcOrd="0" destOrd="0" presId="urn:microsoft.com/office/officeart/2005/8/layout/list1"/>
-    <dgm:cxn modelId="{06F09F63-9944-4CCB-AD2C-3CFB93027BCD}" srcId="{2F2CEC69-05C9-4E48-A0BD-2133202F9F9E}" destId="{BDF4061A-2454-47F8-A1C5-B62B74BA7A4E}" srcOrd="0" destOrd="0" parTransId="{97D940DE-65C1-42B1-932F-F002BE1E95AD}" sibTransId="{43A3D5E4-00E7-4D29-ACCE-3E24C90EF562}"/>
     <dgm:cxn modelId="{2F7AF248-9358-4ACA-9F81-F4ED068AF295}" srcId="{DE9FCB8C-3B64-4C70-AA13-4A877C64E817}" destId="{8E70BE4C-B9FD-49D1-B8A9-9D6E54A7ADF7}" srcOrd="3" destOrd="0" parTransId="{63EE9566-E401-485F-B914-F9BCA99BDE23}" sibTransId="{4145D411-893F-4DBD-A18F-8531DB3D20A9}"/>
     <dgm:cxn modelId="{0884D151-3B97-443E-8D41-2408B5AACE48}" type="presOf" srcId="{B1D35F65-36FB-4D1A-BA81-0C017BE83326}" destId="{379CCEAD-094D-497B-A3AD-5D5A96D2A283}" srcOrd="0" destOrd="0" presId="urn:microsoft.com/office/officeart/2005/8/layout/list1"/>
+    <dgm:cxn modelId="{06F09F63-9944-4CCB-AD2C-3CFB93027BCD}" srcId="{2F2CEC69-05C9-4E48-A0BD-2133202F9F9E}" destId="{BDF4061A-2454-47F8-A1C5-B62B74BA7A4E}" srcOrd="0" destOrd="0" parTransId="{97D940DE-65C1-42B1-932F-F002BE1E95AD}" sibTransId="{43A3D5E4-00E7-4D29-ACCE-3E24C90EF562}"/>
     <dgm:cxn modelId="{A193B97B-64D8-4665-9CB9-93E7562CD70E}" type="presOf" srcId="{8E70BE4C-B9FD-49D1-B8A9-9D6E54A7ADF7}" destId="{145DD6A6-AE81-4536-B4E1-39333503775B}" srcOrd="1" destOrd="0" presId="urn:microsoft.com/office/officeart/2005/8/layout/list1"/>
     <dgm:cxn modelId="{14527F7D-C62E-46CE-A5D2-07547F8ECFFE}" type="presOf" srcId="{BDF4061A-2454-47F8-A1C5-B62B74BA7A4E}" destId="{2A180937-4FE6-4819-9661-EFE0CC42F764}" srcOrd="0" destOrd="0" presId="urn:microsoft.com/office/officeart/2005/8/layout/list1"/>
     <dgm:cxn modelId="{BD134591-2FD7-41EB-97FF-C58F92820A88}" srcId="{8E70BE4C-B9FD-49D1-B8A9-9D6E54A7ADF7}" destId="{B1D35F65-36FB-4D1A-BA81-0C017BE83326}" srcOrd="0" destOrd="0" parTransId="{387B75CB-827F-4589-8CB9-A711E83E0EAA}" sibTransId="{C287F2D2-8C55-4C86-A415-9EB18949967E}"/>
@@ -6792,7 +6800,7 @@
   <dgm:whole/>
   <dgm:extLst>
     <a:ext uri="http://schemas.microsoft.com/office/drawing/2008/diagram">
-      <dsp:dataModelExt xmlns:dsp="http://schemas.microsoft.com/office/drawing/2008/diagram" relId="rId6" minVer="http://schemas.openxmlformats.org/drawingml/2006/diagram"/>
+      <dsp:dataModelExt xmlns:dsp="http://schemas.microsoft.com/office/drawing/2008/diagram" relId="rId7" minVer="http://schemas.openxmlformats.org/drawingml/2006/diagram"/>
     </a:ext>
   </dgm:extLst>
 </dgm:dataModel>
@@ -14633,6 +14641,100 @@
 </p:notes>
 </file>
 
+<file path=ppt/notesSlides/notesSlide2.xml><?xml version="1.0" encoding="utf-8"?>
+<p:notes xmlns:a="http://schemas.openxmlformats.org/drawingml/2006/main" xmlns:r="http://schemas.openxmlformats.org/officeDocument/2006/relationships" xmlns:p="http://schemas.openxmlformats.org/presentationml/2006/main">
+  <p:cSld>
+    <p:spTree>
+      <p:nvGrpSpPr>
+        <p:cNvPr id="1" name=""/>
+        <p:cNvGrpSpPr/>
+        <p:nvPr/>
+      </p:nvGrpSpPr>
+      <p:grpSpPr>
+        <a:xfrm>
+          <a:off x="0" y="0"/>
+          <a:ext cx="0" cy="0"/>
+          <a:chOff x="0" y="0"/>
+          <a:chExt cx="0" cy="0"/>
+        </a:xfrm>
+      </p:grpSpPr>
+      <p:sp>
+        <p:nvSpPr>
+          <p:cNvPr id="2" name="Slide Image Placeholder 1"/>
+          <p:cNvSpPr>
+            <a:spLocks noGrp="1" noRot="1" noChangeAspect="1"/>
+          </p:cNvSpPr>
+          <p:nvPr>
+            <p:ph type="sldImg"/>
+          </p:nvPr>
+        </p:nvSpPr>
+        <p:spPr/>
+      </p:sp>
+      <p:sp>
+        <p:nvSpPr>
+          <p:cNvPr id="3" name="Notes Placeholder 2"/>
+          <p:cNvSpPr>
+            <a:spLocks noGrp="1"/>
+          </p:cNvSpPr>
+          <p:nvPr>
+            <p:ph type="body" idx="1"/>
+          </p:nvPr>
+        </p:nvSpPr>
+        <p:spPr/>
+        <p:txBody>
+          <a:bodyPr/>
+          <a:lstStyle/>
+          <a:p>
+            <a:r>
+              <a:rPr lang="en-US" dirty="0"/>
+              <a:t>https://</a:t>
+            </a:r>
+            <a:r>
+              <a:rPr lang="en-US" dirty="0" err="1"/>
+              <a:t>github.com</a:t>
+            </a:r>
+            <a:r>
+              <a:rPr lang="en-US"/>
+              <a:t>/srajan2627/budget-aware-customer-targeting</a:t>
+            </a:r>
+          </a:p>
+          <a:p>
+            <a:endParaRPr lang="en-US"/>
+          </a:p>
+        </p:txBody>
+      </p:sp>
+      <p:sp>
+        <p:nvSpPr>
+          <p:cNvPr id="4" name="Slide Number Placeholder 3"/>
+          <p:cNvSpPr>
+            <a:spLocks noGrp="1"/>
+          </p:cNvSpPr>
+          <p:nvPr>
+            <p:ph type="sldNum" sz="quarter" idx="5"/>
+          </p:nvPr>
+        </p:nvSpPr>
+        <p:spPr/>
+        <p:txBody>
+          <a:bodyPr/>
+          <a:lstStyle/>
+          <a:p>
+            <a:endParaRPr lang="en-US"/>
+          </a:p>
+        </p:txBody>
+      </p:sp>
+    </p:spTree>
+    <p:extLst>
+      <p:ext uri="{BB962C8B-B14F-4D97-AF65-F5344CB8AC3E}">
+        <p14:creationId xmlns:p14="http://schemas.microsoft.com/office/powerpoint/2010/main" val="779073852"/>
+      </p:ext>
+    </p:extLst>
+  </p:cSld>
+  <p:clrMapOvr>
+    <a:masterClrMapping/>
+  </p:clrMapOvr>
+</p:notes>
+</file>
+
 <file path=ppt/slideLayouts/slideLayout1.xml><?xml version="1.0" encoding="utf-8"?>
 <p:sldLayout xmlns:a="http://schemas.openxmlformats.org/drawingml/2006/main" xmlns:r="http://schemas.openxmlformats.org/officeDocument/2006/relationships" xmlns:p="http://schemas.openxmlformats.org/presentationml/2006/main" showMasterSp="0" preserve="1">
   <p:cSld name="Title with Picture">
@@ -14859,7 +14961,7 @@
           <a:p>
             <a:fld id="{BBB8170F-0370-4A38-8BF3-83D69476AE62}" type="datetime1">
               <a:rPr lang="en-US" smtClean="0"/>
-              <a:t>9/20/2026</a:t>
+              <a:t>9/23/26</a:t>
             </a:fld>
             <a:endParaRPr lang="en-US" dirty="0"/>
           </a:p>
@@ -15209,7 +15311,7 @@
           <a:p>
             <a:fld id="{491FA625-EDE8-4CCD-93F2-36B8EAED6AA1}" type="datetime1">
               <a:rPr lang="en-US" smtClean="0"/>
-              <a:t>9/20/2026</a:t>
+              <a:t>9/23/26</a:t>
             </a:fld>
             <a:endParaRPr lang="en-US"/>
           </a:p>
@@ -15526,7 +15628,7 @@
           <a:p>
             <a:fld id="{5824A7B9-17B9-4425-9158-739F678A55EB}" type="datetime1">
               <a:rPr lang="en-US" smtClean="0"/>
-              <a:t>9/20/2026</a:t>
+              <a:t>9/23/26</a:t>
             </a:fld>
             <a:endParaRPr lang="en-US" dirty="0"/>
           </a:p>
@@ -15792,7 +15894,7 @@
           <a:p>
             <a:fld id="{28E8FF4C-7F6A-4962-9270-F797B8959287}" type="datetime1">
               <a:rPr lang="en-US" smtClean="0"/>
-              <a:t>9/20/2026</a:t>
+              <a:t>9/23/26</a:t>
             </a:fld>
             <a:endParaRPr lang="en-US"/>
           </a:p>
@@ -16114,7 +16216,7 @@
           <a:p>
             <a:fld id="{064F86E1-145A-4683-AD05-97E7E41B4995}" type="datetime1">
               <a:rPr lang="en-US" smtClean="0"/>
-              <a:t>9/20/2026</a:t>
+              <a:t>9/23/26</a:t>
             </a:fld>
             <a:endParaRPr lang="en-US" dirty="0"/>
           </a:p>
@@ -16438,7 +16540,7 @@
           <a:p>
             <a:fld id="{96B14CE5-CB23-4F24-AF40-FFA10F25B799}" type="datetime1">
               <a:rPr lang="en-US" smtClean="0"/>
-              <a:t>9/20/2026</a:t>
+              <a:t>9/23/26</a:t>
             </a:fld>
             <a:endParaRPr lang="en-US"/>
           </a:p>
@@ -16750,7 +16852,7 @@
           <a:p>
             <a:fld id="{C939A3FF-4925-4C53-B6D9-F2B1807D4179}" type="datetime1">
               <a:rPr lang="en-US" smtClean="0"/>
-              <a:t>9/20/2026</a:t>
+              <a:t>9/23/26</a:t>
             </a:fld>
             <a:endParaRPr lang="en-US"/>
           </a:p>
@@ -17260,7 +17362,7 @@
           <a:p>
             <a:fld id="{220747AD-BB60-464B-B16B-6CC7DCEAA31E}" type="datetime1">
               <a:rPr lang="en-US" smtClean="0"/>
-              <a:t>9/20/2026</a:t>
+              <a:t>9/23/26</a:t>
             </a:fld>
             <a:endParaRPr lang="en-US"/>
           </a:p>
@@ -17508,7 +17610,7 @@
           <a:p>
             <a:fld id="{B340F08F-40FA-4D3B-96CF-F8FAF483E9A7}" type="datetime1">
               <a:rPr lang="en-US" smtClean="0"/>
-              <a:t>9/20/2026</a:t>
+              <a:t>9/23/26</a:t>
             </a:fld>
             <a:endParaRPr lang="en-US"/>
           </a:p>
@@ -17870,7 +17972,7 @@
           <a:p>
             <a:fld id="{EB5EDF0F-3515-4895-B663-882304741893}" type="datetime1">
               <a:rPr lang="en-US" smtClean="0"/>
-              <a:t>9/20/2026</a:t>
+              <a:t>9/23/26</a:t>
             </a:fld>
             <a:endParaRPr lang="en-US"/>
           </a:p>
@@ -18354,7 +18456,7 @@
           <a:p>
             <a:fld id="{05B29ED0-7871-4976-8402-1756C1FAC1EA}" type="datetime1">
               <a:rPr lang="en-US" smtClean="0"/>
-              <a:t>9/20/2026</a:t>
+              <a:t>9/23/26</a:t>
             </a:fld>
             <a:endParaRPr lang="en-US"/>
           </a:p>
@@ -18633,7 +18735,7 @@
           <a:p>
             <a:fld id="{20D15516-589F-487D-BF51-9635DCEA90D5}" type="datetime1">
               <a:rPr lang="en-US" smtClean="0"/>
-              <a:t>9/20/2026</a:t>
+              <a:t>9/23/26</a:t>
             </a:fld>
             <a:endParaRPr lang="en-US"/>
           </a:p>
@@ -18961,7 +19063,7 @@
           <a:p>
             <a:fld id="{453B8C54-B76A-4DD8-BD0B-11200408342B}" type="datetime1">
               <a:rPr lang="en-US" smtClean="0"/>
-              <a:t>9/20/2026</a:t>
+              <a:t>9/23/26</a:t>
             </a:fld>
             <a:endParaRPr lang="en-US" dirty="0"/>
           </a:p>
@@ -19304,7 +19406,7 @@
           <a:p>
             <a:fld id="{15448BDD-274C-4BED-8350-833672089118}" type="datetime1">
               <a:rPr lang="en-US" smtClean="0"/>
-              <a:t>9/20/2026</a:t>
+              <a:t>9/23/26</a:t>
             </a:fld>
             <a:endParaRPr lang="en-US" dirty="0"/>
           </a:p>
@@ -19560,7 +19662,7 @@
           <a:p>
             <a:fld id="{9EAD527F-9C49-4481-A18C-80BA2EA99E79}" type="datetime1">
               <a:rPr lang="en-US" smtClean="0"/>
-              <a:t>9/20/2026</a:t>
+              <a:t>9/23/26</a:t>
             </a:fld>
             <a:endParaRPr lang="en-US"/>
           </a:p>
@@ -19886,7 +19988,7 @@
           <a:p>
             <a:fld id="{F38039EB-95FD-42A0-BF06-87A9D15142C9}" type="datetime1">
               <a:rPr lang="en-US" smtClean="0"/>
-              <a:t>9/20/2026</a:t>
+              <a:t>9/23/26</a:t>
             </a:fld>
             <a:endParaRPr lang="en-US"/>
           </a:p>
@@ -20353,7 +20455,7 @@
           <a:p>
             <a:fld id="{6819701D-AA71-4F6F-B74A-236E07E9ABE4}" type="datetime1">
               <a:rPr lang="en-US" smtClean="0"/>
-              <a:t>9/20/2026</a:t>
+              <a:t>9/23/26</a:t>
             </a:fld>
             <a:endParaRPr lang="en-US"/>
           </a:p>
@@ -20469,7 +20571,7 @@
           <a:p>
             <a:fld id="{A886D589-8B08-4190-9F3B-BA01ED2999CB}" type="datetime1">
               <a:rPr lang="en-US" smtClean="0"/>
-              <a:t>9/20/2026</a:t>
+              <a:t>9/23/26</a:t>
             </a:fld>
             <a:endParaRPr lang="en-US"/>
           </a:p>
@@ -20700,7 +20802,7 @@
           <a:p>
             <a:fld id="{12A08923-D58E-4822-B554-6A1173FCE25D}" type="datetime1">
               <a:rPr lang="en-US" smtClean="0"/>
-              <a:t>9/20/2026</a:t>
+              <a:t>9/23/26</a:t>
             </a:fld>
             <a:endParaRPr lang="en-US" dirty="0"/>
           </a:p>
@@ -21068,7 +21170,7 @@
           <a:p>
             <a:fld id="{F50BF9E0-60DA-4D6D-8F14-825F152220D6}" type="datetime1">
               <a:rPr lang="en-US" smtClean="0"/>
-              <a:t>9/20/2026</a:t>
+              <a:t>9/23/26</a:t>
             </a:fld>
             <a:endParaRPr lang="en-US"/>
           </a:p>
@@ -21386,7 +21488,7 @@
           <a:p>
             <a:fld id="{BD5D1244-0536-4076-95F8-65E3144966FF}" type="datetime1">
               <a:rPr lang="en-US" smtClean="0"/>
-              <a:t>9/20/2026</a:t>
+              <a:t>9/23/26</a:t>
             </a:fld>
             <a:endParaRPr lang="en-US"/>
           </a:p>
@@ -21677,7 +21779,7 @@
           <a:p>
             <a:fld id="{E8F94E15-B448-489B-871D-A40527BFA7B7}" type="datetime1">
               <a:rPr lang="en-US" smtClean="0"/>
-              <a:t>9/20/2026</a:t>
+              <a:t>9/23/26</a:t>
             </a:fld>
             <a:endParaRPr lang="en-US"/>
           </a:p>
@@ -21955,7 +22057,7 @@
           <a:p>
             <a:fld id="{CE994A23-0EFF-404D-A2C5-6B54939039AD}" type="datetime1">
               <a:rPr lang="en-US" smtClean="0"/>
-              <a:t>9/20/2026</a:t>
+              <a:t>9/23/26</a:t>
             </a:fld>
             <a:endParaRPr lang="en-US"/>
           </a:p>
@@ -22257,7 +22359,7 @@
           <a:p>
             <a:fld id="{D9D311C3-93DB-42DC-917F-4386F19A1E3B}" type="datetime1">
               <a:rPr lang="en-US" smtClean="0"/>
-              <a:t>9/20/2026</a:t>
+              <a:t>9/23/26</a:t>
             </a:fld>
             <a:endParaRPr lang="en-US"/>
           </a:p>
@@ -22650,7 +22752,7 @@
           <a:p>
             <a:fld id="{948C47DC-C479-4517-B1B0-94DB01BA76E7}" type="datetime1">
               <a:rPr lang="en-US" smtClean="0"/>
-              <a:t>9/20/2026</a:t>
+              <a:t>9/23/26</a:t>
             </a:fld>
             <a:endParaRPr lang="en-US"/>
           </a:p>
@@ -22961,7 +23063,7 @@
           <a:p>
             <a:fld id="{F92C9D0B-C1A3-434D-9CF9-A666A14DD8A1}" type="datetime1">
               <a:rPr lang="en-US" smtClean="0"/>
-              <a:t>9/20/2026</a:t>
+              <a:t>9/23/26</a:t>
             </a:fld>
             <a:endParaRPr lang="en-US"/>
           </a:p>
@@ -23315,7 +23417,7 @@
           <a:p>
             <a:fld id="{742A22FE-7CAA-4561-B3B2-F8D8C37BE3D2}" type="datetime1">
               <a:rPr lang="en-US" smtClean="0"/>
-              <a:t>9/20/2026</a:t>
+              <a:t>9/23/26</a:t>
             </a:fld>
             <a:endParaRPr lang="en-US"/>
           </a:p>
@@ -23665,7 +23767,7 @@
           <a:p>
             <a:fld id="{18A4B20A-718A-4149-B5D2-676E857EB828}" type="datetime1">
               <a:rPr lang="en-US" smtClean="0"/>
-              <a:t>9/20/2026</a:t>
+              <a:t>9/23/26</a:t>
             </a:fld>
             <a:endParaRPr lang="en-US"/>
           </a:p>
@@ -24459,7 +24561,7 @@
         </p:xfrm>
         <a:graphic>
           <a:graphicData uri="http://schemas.openxmlformats.org/drawingml/2006/diagram">
-            <dgm:relIds xmlns:dgm="http://schemas.openxmlformats.org/drawingml/2006/diagram" xmlns:r="http://schemas.openxmlformats.org/officeDocument/2006/relationships" r:dm="rId2" r:lo="rId3" r:qs="rId4" r:cs="rId5"/>
+            <dgm:relIds xmlns:dgm="http://schemas.openxmlformats.org/drawingml/2006/diagram" xmlns:r="http://schemas.openxmlformats.org/officeDocument/2006/relationships" r:dm="rId3" r:lo="rId4" r:qs="rId5" r:cs="rId6"/>
           </a:graphicData>
         </a:graphic>
       </p:graphicFrame>

</xml_diff>